<commit_message>
Refresh the PACMAN curriculum notebook and ExoCore presentation
</commit_message>
<xml_diff>
--- a/ExoCore/Exocore.pptx
+++ b/ExoCore/Exocore.pptx
@@ -10682,7 +10682,11 @@
           <a:lstStyle/>
           <a:p>
             <a:r>
-              <a:rPr lang="en-US" sz="5400" b="1" dirty="0"/>
+              <a:rPr lang="en-US" sz="5400" b="1" dirty="0">
+                <a:solidFill>
+                  <a:srgbClr val="A51417"/>
+                </a:solidFill>
+              </a:rPr>
               <a:t>Exocore</a:t>
             </a:r>
             <a:endParaRPr lang="en-US" b="1" dirty="0"/>
@@ -10743,7 +10747,11 @@
           <a:lstStyle/>
           <a:p>
             <a:r>
-              <a:rPr lang="en-US" sz="4400" dirty="0"/>
+              <a:rPr lang="en-US" sz="4400" dirty="0">
+                <a:solidFill>
+                  <a:srgbClr val="A51417"/>
+                </a:solidFill>
+              </a:rPr>
               <a:t>What is exocore?</a:t>
             </a:r>
           </a:p>
@@ -10948,7 +10956,11 @@
           <a:lstStyle/>
           <a:p>
             <a:r>
-              <a:rPr lang="en-US" sz="4400" dirty="0"/>
+              <a:rPr lang="en-US" sz="4400" dirty="0">
+                <a:solidFill>
+                  <a:srgbClr val="A51417"/>
+                </a:solidFill>
+              </a:rPr>
               <a:t>Learning Objectives</a:t>
             </a:r>
           </a:p>
@@ -11205,7 +11217,11 @@
           <a:lstStyle/>
           <a:p>
             <a:r>
-              <a:rPr lang="en-US" sz="4400" dirty="0"/>
+              <a:rPr lang="en-US" sz="4400" dirty="0">
+                <a:solidFill>
+                  <a:srgbClr val="A51417"/>
+                </a:solidFill>
+              </a:rPr>
               <a:t>Exocore Structure</a:t>
             </a:r>
           </a:p>

</xml_diff>